<commit_message>
docs: update WarriorFit technical presentation (NL)
</commit_message>
<xml_diff>
--- a/documentation/WarriorFit_Pitch_Sequoia_NL.pptx
+++ b/documentation/WarriorFit_Pitch_Sequoia_NL.pptx
@@ -217,7 +217,7 @@
           <a:p>
             <a:fld id="{B6D4A502-5F08-B140-AD9B-A3AFF21258ED}" type="datetimeFigureOut">
               <a:rPr lang="en-BE" smtClean="0"/>
-              <a:t>17/06/2026</a:t>
+              <a:t>18/06/2026</a:t>
             </a:fld>
             <a:endParaRPr lang="en-BE"/>
           </a:p>
@@ -1489,7 +1489,7 @@
           <a:p>
             <a:fld id="{5BCAD085-E8A6-8845-BD4E-CB4CCA059FC4}" type="datetimeFigureOut">
               <a:rPr lang="en-US" smtClean="0"/>
-              <a:t>6/17/26</a:t>
+              <a:t>6/18/26</a:t>
             </a:fld>
             <a:endParaRPr lang="en-US"/>
           </a:p>
@@ -1657,7 +1657,7 @@
           <a:p>
             <a:fld id="{5BCAD085-E8A6-8845-BD4E-CB4CCA059FC4}" type="datetimeFigureOut">
               <a:rPr lang="en-US" smtClean="0"/>
-              <a:t>6/17/26</a:t>
+              <a:t>6/18/26</a:t>
             </a:fld>
             <a:endParaRPr lang="en-US"/>
           </a:p>
@@ -1835,7 +1835,7 @@
           <a:p>
             <a:fld id="{5BCAD085-E8A6-8845-BD4E-CB4CCA059FC4}" type="datetimeFigureOut">
               <a:rPr lang="en-US" smtClean="0"/>
-              <a:t>6/17/26</a:t>
+              <a:t>6/18/26</a:t>
             </a:fld>
             <a:endParaRPr lang="en-US"/>
           </a:p>
@@ -2003,7 +2003,7 @@
           <a:p>
             <a:fld id="{5BCAD085-E8A6-8845-BD4E-CB4CCA059FC4}" type="datetimeFigureOut">
               <a:rPr lang="en-US" smtClean="0"/>
-              <a:t>6/17/26</a:t>
+              <a:t>6/18/26</a:t>
             </a:fld>
             <a:endParaRPr lang="en-US"/>
           </a:p>
@@ -2248,7 +2248,7 @@
           <a:p>
             <a:fld id="{5BCAD085-E8A6-8845-BD4E-CB4CCA059FC4}" type="datetimeFigureOut">
               <a:rPr lang="en-US" smtClean="0"/>
-              <a:t>6/17/26</a:t>
+              <a:t>6/18/26</a:t>
             </a:fld>
             <a:endParaRPr lang="en-US"/>
           </a:p>
@@ -2533,7 +2533,7 @@
           <a:p>
             <a:fld id="{5BCAD085-E8A6-8845-BD4E-CB4CCA059FC4}" type="datetimeFigureOut">
               <a:rPr lang="en-US" smtClean="0"/>
-              <a:t>6/17/26</a:t>
+              <a:t>6/18/26</a:t>
             </a:fld>
             <a:endParaRPr lang="en-US"/>
           </a:p>
@@ -2952,7 +2952,7 @@
           <a:p>
             <a:fld id="{5BCAD085-E8A6-8845-BD4E-CB4CCA059FC4}" type="datetimeFigureOut">
               <a:rPr lang="en-US" smtClean="0"/>
-              <a:t>6/17/26</a:t>
+              <a:t>6/18/26</a:t>
             </a:fld>
             <a:endParaRPr lang="en-US"/>
           </a:p>
@@ -3069,7 +3069,7 @@
           <a:p>
             <a:fld id="{5BCAD085-E8A6-8845-BD4E-CB4CCA059FC4}" type="datetimeFigureOut">
               <a:rPr lang="en-US" smtClean="0"/>
-              <a:t>6/17/26</a:t>
+              <a:t>6/18/26</a:t>
             </a:fld>
             <a:endParaRPr lang="en-US"/>
           </a:p>
@@ -3164,7 +3164,7 @@
           <a:p>
             <a:fld id="{5BCAD085-E8A6-8845-BD4E-CB4CCA059FC4}" type="datetimeFigureOut">
               <a:rPr lang="en-US" smtClean="0"/>
-              <a:t>6/17/26</a:t>
+              <a:t>6/18/26</a:t>
             </a:fld>
             <a:endParaRPr lang="en-US"/>
           </a:p>
@@ -3439,7 +3439,7 @@
           <a:p>
             <a:fld id="{5BCAD085-E8A6-8845-BD4E-CB4CCA059FC4}" type="datetimeFigureOut">
               <a:rPr lang="en-US" smtClean="0"/>
-              <a:t>6/17/26</a:t>
+              <a:t>6/18/26</a:t>
             </a:fld>
             <a:endParaRPr lang="en-US"/>
           </a:p>
@@ -3691,7 +3691,7 @@
           <a:p>
             <a:fld id="{5BCAD085-E8A6-8845-BD4E-CB4CCA059FC4}" type="datetimeFigureOut">
               <a:rPr lang="en-US" smtClean="0"/>
-              <a:t>6/17/26</a:t>
+              <a:t>6/18/26</a:t>
             </a:fld>
             <a:endParaRPr lang="en-US"/>
           </a:p>
@@ -3902,7 +3902,7 @@
           <a:p>
             <a:fld id="{5BCAD085-E8A6-8845-BD4E-CB4CCA059FC4}" type="datetimeFigureOut">
               <a:rPr lang="en-US" smtClean="0"/>
-              <a:t>6/17/26</a:t>
+              <a:t>6/18/26</a:t>
             </a:fld>
             <a:endParaRPr lang="en-US"/>
           </a:p>
@@ -5809,7 +5809,7 @@
         <p:spPr>
           <a:xfrm>
             <a:off x="4297680" y="3611880"/>
-            <a:ext cx="3566160" cy="2743200"/>
+            <a:ext cx="3566160" cy="954107"/>
           </a:xfrm>
           <a:prstGeom prst="rect">
             <a:avLst/>
@@ -5824,19 +5824,34 @@
           <a:p>
             <a:pPr algn="l"/>
             <a:r>
-              <a:rPr sz="1400" b="0">
+              <a:rPr sz="1400" b="0" dirty="0">
                 <a:solidFill>
                   <a:srgbClr val="222222"/>
                 </a:solidFill>
                 <a:latin typeface="Calibri"/>
               </a:rPr>
-              <a:t>→  Dashboard per eenheid</a:t>
-            </a:r>
+              <a:t>→  Dashboard per </a:t>
+            </a:r>
+            <a:r>
+              <a:rPr sz="1400" b="0" dirty="0" err="1">
+                <a:solidFill>
+                  <a:srgbClr val="222222"/>
+                </a:solidFill>
+                <a:latin typeface="Calibri"/>
+              </a:rPr>
+              <a:t>eenheid</a:t>
+            </a:r>
+            <a:endParaRPr sz="1400" b="0" dirty="0">
+              <a:solidFill>
+                <a:srgbClr val="222222"/>
+              </a:solidFill>
+              <a:latin typeface="Calibri"/>
+            </a:endParaRPr>
           </a:p>
           <a:p>
             <a:pPr algn="l"/>
             <a:r>
-              <a:rPr sz="1400" b="0">
+              <a:rPr sz="1400" b="0" dirty="0">
                 <a:solidFill>
                   <a:srgbClr val="222222"/>
                 </a:solidFill>
@@ -5848,37 +5863,43 @@
           <a:p>
             <a:pPr algn="l"/>
             <a:r>
-              <a:rPr sz="1400" b="0">
+              <a:rPr sz="1400" b="0" dirty="0">
                 <a:solidFill>
                   <a:srgbClr val="222222"/>
                 </a:solidFill>
                 <a:latin typeface="Calibri"/>
               </a:rPr>
-              <a:t>→  Individueel PDF-rapport</a:t>
+              <a:t>→  </a:t>
+            </a:r>
+            <a:r>
+              <a:rPr sz="1400" b="0" dirty="0" err="1">
+                <a:solidFill>
+                  <a:srgbClr val="222222"/>
+                </a:solidFill>
+                <a:latin typeface="Calibri"/>
+              </a:rPr>
+              <a:t>Individueel</a:t>
+            </a:r>
+            <a:r>
+              <a:rPr sz="1400" b="0" dirty="0">
+                <a:solidFill>
+                  <a:srgbClr val="222222"/>
+                </a:solidFill>
+                <a:latin typeface="Calibri"/>
+              </a:rPr>
+              <a:t> PDF-rapport</a:t>
             </a:r>
           </a:p>
           <a:p>
             <a:pPr algn="l"/>
             <a:r>
-              <a:rPr sz="1400" b="0">
+              <a:rPr sz="1400" b="0" dirty="0">
                 <a:solidFill>
                   <a:srgbClr val="222222"/>
                 </a:solidFill>
                 <a:latin typeface="Calibri"/>
               </a:rPr>
               <a:t>→  CSV + landscape A4 PDF export</a:t>
-            </a:r>
-          </a:p>
-          <a:p>
-            <a:pPr algn="l"/>
-            <a:r>
-              <a:rPr sz="1400" b="0">
-                <a:solidFill>
-                  <a:srgbClr val="222222"/>
-                </a:solidFill>
-                <a:latin typeface="Calibri"/>
-              </a:rPr>
-              <a:t>→  Eigen unit + sub-eenheid filter</a:t>
             </a:r>
           </a:p>
         </p:txBody>
@@ -5986,55 +6007,136 @@
           <a:p>
             <a:pPr algn="l"/>
             <a:r>
-              <a:rPr sz="1400" b="0">
+              <a:rPr sz="1400" b="0" dirty="0">
                 <a:solidFill>
                   <a:srgbClr val="222222"/>
                 </a:solidFill>
                 <a:latin typeface="Calibri"/>
               </a:rPr>
-              <a:t>→  BEMIL-koppeling (HR-broker)</a:t>
+              <a:t>→  BEMIL-</a:t>
+            </a:r>
+            <a:r>
+              <a:rPr sz="1400" b="0" dirty="0" err="1">
+                <a:solidFill>
+                  <a:srgbClr val="222222"/>
+                </a:solidFill>
+                <a:latin typeface="Calibri"/>
+              </a:rPr>
+              <a:t>koppeling</a:t>
+            </a:r>
+            <a:r>
+              <a:rPr sz="1400" b="0" dirty="0">
+                <a:solidFill>
+                  <a:srgbClr val="222222"/>
+                </a:solidFill>
+                <a:latin typeface="Calibri"/>
+              </a:rPr>
+              <a:t> (HR-broker)</a:t>
             </a:r>
           </a:p>
           <a:p>
             <a:pPr algn="l"/>
             <a:r>
-              <a:rPr sz="1400" b="0">
+              <a:rPr sz="1400" b="0" dirty="0">
                 <a:solidFill>
                   <a:srgbClr val="222222"/>
                 </a:solidFill>
                 <a:latin typeface="Calibri"/>
               </a:rPr>
-              <a:t>→  AVG: consent, export, retentie</a:t>
-            </a:r>
+              <a:t>→  AVG: consent, export, </a:t>
+            </a:r>
+            <a:r>
+              <a:rPr sz="1400" b="0" dirty="0" err="1">
+                <a:solidFill>
+                  <a:srgbClr val="222222"/>
+                </a:solidFill>
+                <a:latin typeface="Calibri"/>
+              </a:rPr>
+              <a:t>retentie</a:t>
+            </a:r>
+            <a:endParaRPr sz="1400" b="0" dirty="0">
+              <a:solidFill>
+                <a:srgbClr val="222222"/>
+              </a:solidFill>
+              <a:latin typeface="Calibri"/>
+            </a:endParaRPr>
           </a:p>
           <a:p>
             <a:pPr algn="l"/>
             <a:r>
-              <a:rPr sz="1400" b="0">
+              <a:rPr sz="1400" b="0" dirty="0">
                 <a:solidFill>
                   <a:srgbClr val="222222"/>
                 </a:solidFill>
                 <a:latin typeface="Calibri"/>
               </a:rPr>
-              <a:t>→  RBAC: 6 rollen, OWASP-gehard</a:t>
-            </a:r>
+              <a:t>→  RBAC: 6 </a:t>
+            </a:r>
+            <a:r>
+              <a:rPr sz="1400" b="0" dirty="0" err="1">
+                <a:solidFill>
+                  <a:srgbClr val="222222"/>
+                </a:solidFill>
+                <a:latin typeface="Calibri"/>
+              </a:rPr>
+              <a:t>rollen</a:t>
+            </a:r>
+            <a:r>
+              <a:rPr sz="1400" b="0" dirty="0">
+                <a:solidFill>
+                  <a:srgbClr val="222222"/>
+                </a:solidFill>
+                <a:latin typeface="Calibri"/>
+              </a:rPr>
+              <a:t>, OWASP-</a:t>
+            </a:r>
+            <a:r>
+              <a:rPr sz="1400" b="0" dirty="0" err="1">
+                <a:solidFill>
+                  <a:srgbClr val="222222"/>
+                </a:solidFill>
+                <a:latin typeface="Calibri"/>
+              </a:rPr>
+              <a:t>gehard</a:t>
+            </a:r>
+            <a:endParaRPr sz="1400" b="0" dirty="0">
+              <a:solidFill>
+                <a:srgbClr val="222222"/>
+              </a:solidFill>
+              <a:latin typeface="Calibri"/>
+            </a:endParaRPr>
           </a:p>
           <a:p>
             <a:pPr algn="l"/>
             <a:r>
-              <a:rPr sz="1400" b="0">
+              <a:rPr sz="1400" b="0" dirty="0">
                 <a:solidFill>
                   <a:srgbClr val="222222"/>
                 </a:solidFill>
                 <a:latin typeface="Calibri"/>
               </a:rPr>
-              <a:t>→  EN / NL / FR meertalig</a:t>
-            </a:r>
+              <a:t>→  EN / NL / FR </a:t>
+            </a:r>
+            <a:r>
+              <a:rPr sz="1400" b="0" dirty="0" err="1">
+                <a:solidFill>
+                  <a:srgbClr val="222222"/>
+                </a:solidFill>
+                <a:latin typeface="Calibri"/>
+              </a:rPr>
+              <a:t>meertalig</a:t>
+            </a:r>
+            <a:endParaRPr sz="1400" b="0" dirty="0">
+              <a:solidFill>
+                <a:srgbClr val="222222"/>
+              </a:solidFill>
+              <a:latin typeface="Calibri"/>
+            </a:endParaRPr>
           </a:p>
           <a:p>
             <a:pPr algn="l"/>
             <a:r>
-              <a:rPr sz="1400" b="0">
+              <a:rPr sz="1400" b="0" dirty="0">
                 <a:solidFill>
                   <a:srgbClr val="222222"/>
                 </a:solidFill>
@@ -10824,7 +10926,7 @@
 </file>
 
 <file path=ppt/slides/slide7.xml><?xml version="1.0" encoding="utf-8"?>
-<p:sld xmlns:a="http://schemas.openxmlformats.org/drawingml/2006/main" xmlns:r="http://schemas.openxmlformats.org/officeDocument/2006/relationships" xmlns:p="http://schemas.openxmlformats.org/presentationml/2006/main">
+<p:sld xmlns:a="http://schemas.openxmlformats.org/drawingml/2006/main" xmlns:r="http://schemas.openxmlformats.org/officeDocument/2006/relationships" xmlns:p="http://schemas.openxmlformats.org/presentationml/2006/main" show="0">
   <p:cSld>
     <p:spTree>
       <p:nvGrpSpPr>

</xml_diff>

<commit_message>
docs: enhance installation guide with configuration, database setup, and Docker deployment steps
Expanded the WarriorFit installation guide to include detailed sections on environment-specific configurations, runtime secrets, database setup options, and Docker deployment procedures with test and production setups. Simplified existing explanations and improved example clarity.
</commit_message>
<xml_diff>
--- a/documentation/WarriorFit_Pitch_Sequoia_NL.pptx
+++ b/documentation/WarriorFit_Pitch_Sequoia_NL.pptx
@@ -5,7 +5,7 @@
     <p:sldMasterId id="2147483648" r:id="rId1"/>
   </p:sldMasterIdLst>
   <p:notesMasterIdLst>
-    <p:notesMasterId r:id="rId12"/>
+    <p:notesMasterId r:id="rId11"/>
   </p:notesMasterIdLst>
   <p:sldIdLst>
     <p:sldId id="256" r:id="rId2"/>
@@ -16,8 +16,7 @@
     <p:sldId id="261" r:id="rId7"/>
     <p:sldId id="262" r:id="rId8"/>
     <p:sldId id="263" r:id="rId9"/>
-    <p:sldId id="264" r:id="rId10"/>
-    <p:sldId id="265" r:id="rId11"/>
+    <p:sldId id="265" r:id="rId10"/>
   </p:sldIdLst>
   <p:sldSz cx="12192000" cy="6858000"/>
   <p:notesSz cx="6858000" cy="9144000"/>
@@ -217,7 +216,7 @@
           <a:p>
             <a:fld id="{B6D4A502-5F08-B140-AD9B-A3AFF21258ED}" type="datetimeFigureOut">
               <a:rPr lang="en-BE" smtClean="0"/>
-              <a:t>18/06/2026</a:t>
+              <a:t>6/22/26</a:t>
             </a:fld>
             <a:endParaRPr lang="en-BE"/>
           </a:p>
@@ -1489,7 +1488,7 @@
           <a:p>
             <a:fld id="{5BCAD085-E8A6-8845-BD4E-CB4CCA059FC4}" type="datetimeFigureOut">
               <a:rPr lang="en-US" smtClean="0"/>
-              <a:t>6/18/26</a:t>
+              <a:t>6/22/26</a:t>
             </a:fld>
             <a:endParaRPr lang="en-US"/>
           </a:p>
@@ -1657,7 +1656,7 @@
           <a:p>
             <a:fld id="{5BCAD085-E8A6-8845-BD4E-CB4CCA059FC4}" type="datetimeFigureOut">
               <a:rPr lang="en-US" smtClean="0"/>
-              <a:t>6/18/26</a:t>
+              <a:t>6/22/26</a:t>
             </a:fld>
             <a:endParaRPr lang="en-US"/>
           </a:p>
@@ -1835,7 +1834,7 @@
           <a:p>
             <a:fld id="{5BCAD085-E8A6-8845-BD4E-CB4CCA059FC4}" type="datetimeFigureOut">
               <a:rPr lang="en-US" smtClean="0"/>
-              <a:t>6/18/26</a:t>
+              <a:t>6/22/26</a:t>
             </a:fld>
             <a:endParaRPr lang="en-US"/>
           </a:p>
@@ -2003,7 +2002,7 @@
           <a:p>
             <a:fld id="{5BCAD085-E8A6-8845-BD4E-CB4CCA059FC4}" type="datetimeFigureOut">
               <a:rPr lang="en-US" smtClean="0"/>
-              <a:t>6/18/26</a:t>
+              <a:t>6/22/26</a:t>
             </a:fld>
             <a:endParaRPr lang="en-US"/>
           </a:p>
@@ -2248,7 +2247,7 @@
           <a:p>
             <a:fld id="{5BCAD085-E8A6-8845-BD4E-CB4CCA059FC4}" type="datetimeFigureOut">
               <a:rPr lang="en-US" smtClean="0"/>
-              <a:t>6/18/26</a:t>
+              <a:t>6/22/26</a:t>
             </a:fld>
             <a:endParaRPr lang="en-US"/>
           </a:p>
@@ -2533,7 +2532,7 @@
           <a:p>
             <a:fld id="{5BCAD085-E8A6-8845-BD4E-CB4CCA059FC4}" type="datetimeFigureOut">
               <a:rPr lang="en-US" smtClean="0"/>
-              <a:t>6/18/26</a:t>
+              <a:t>6/22/26</a:t>
             </a:fld>
             <a:endParaRPr lang="en-US"/>
           </a:p>
@@ -2952,7 +2951,7 @@
           <a:p>
             <a:fld id="{5BCAD085-E8A6-8845-BD4E-CB4CCA059FC4}" type="datetimeFigureOut">
               <a:rPr lang="en-US" smtClean="0"/>
-              <a:t>6/18/26</a:t>
+              <a:t>6/22/26</a:t>
             </a:fld>
             <a:endParaRPr lang="en-US"/>
           </a:p>
@@ -3069,7 +3068,7 @@
           <a:p>
             <a:fld id="{5BCAD085-E8A6-8845-BD4E-CB4CCA059FC4}" type="datetimeFigureOut">
               <a:rPr lang="en-US" smtClean="0"/>
-              <a:t>6/18/26</a:t>
+              <a:t>6/22/26</a:t>
             </a:fld>
             <a:endParaRPr lang="en-US"/>
           </a:p>
@@ -3164,7 +3163,7 @@
           <a:p>
             <a:fld id="{5BCAD085-E8A6-8845-BD4E-CB4CCA059FC4}" type="datetimeFigureOut">
               <a:rPr lang="en-US" smtClean="0"/>
-              <a:t>6/18/26</a:t>
+              <a:t>6/22/26</a:t>
             </a:fld>
             <a:endParaRPr lang="en-US"/>
           </a:p>
@@ -3439,7 +3438,7 @@
           <a:p>
             <a:fld id="{5BCAD085-E8A6-8845-BD4E-CB4CCA059FC4}" type="datetimeFigureOut">
               <a:rPr lang="en-US" smtClean="0"/>
-              <a:t>6/18/26</a:t>
+              <a:t>6/22/26</a:t>
             </a:fld>
             <a:endParaRPr lang="en-US"/>
           </a:p>
@@ -3691,7 +3690,7 @@
           <a:p>
             <a:fld id="{5BCAD085-E8A6-8845-BD4E-CB4CCA059FC4}" type="datetimeFigureOut">
               <a:rPr lang="en-US" smtClean="0"/>
-              <a:t>6/18/26</a:t>
+              <a:t>6/22/26</a:t>
             </a:fld>
             <a:endParaRPr lang="en-US"/>
           </a:p>
@@ -3902,7 +3901,7 @@
           <a:p>
             <a:fld id="{5BCAD085-E8A6-8845-BD4E-CB4CCA059FC4}" type="datetimeFigureOut">
               <a:rPr lang="en-US" smtClean="0"/>
-              <a:t>6/18/26</a:t>
+              <a:t>6/22/26</a:t>
             </a:fld>
             <a:endParaRPr lang="en-US"/>
           </a:p>
@@ -4549,739 +4548,6 @@
 </p:sld>
 </file>
 
-<file path=ppt/slides/slide10.xml><?xml version="1.0" encoding="utf-8"?>
-<p:sld xmlns:a="http://schemas.openxmlformats.org/drawingml/2006/main" xmlns:r="http://schemas.openxmlformats.org/officeDocument/2006/relationships" xmlns:p="http://schemas.openxmlformats.org/presentationml/2006/main">
-  <p:cSld>
-    <p:spTree>
-      <p:nvGrpSpPr>
-        <p:cNvPr id="1" name=""/>
-        <p:cNvGrpSpPr/>
-        <p:nvPr/>
-      </p:nvGrpSpPr>
-      <p:grpSpPr>
-        <a:xfrm>
-          <a:off x="0" y="0"/>
-          <a:ext cx="0" cy="0"/>
-          <a:chOff x="0" y="0"/>
-          <a:chExt cx="0" cy="0"/>
-        </a:xfrm>
-      </p:grpSpPr>
-      <p:sp>
-        <p:nvSpPr>
-          <p:cNvPr id="2" name="Rectangle 1"/>
-          <p:cNvSpPr/>
-          <p:nvPr/>
-        </p:nvSpPr>
-        <p:spPr>
-          <a:xfrm>
-            <a:off x="0" y="0"/>
-            <a:ext cx="12191695" cy="6858000"/>
-          </a:xfrm>
-          <a:prstGeom prst="rect">
-            <a:avLst/>
-          </a:prstGeom>
-          <a:solidFill>
-            <a:srgbClr val="334218"/>
-          </a:solidFill>
-          <a:ln>
-            <a:noFill/>
-          </a:ln>
-          <a:effectLst/>
-        </p:spPr>
-        <p:style>
-          <a:lnRef idx="1">
-            <a:schemeClr val="accent1"/>
-          </a:lnRef>
-          <a:fillRef idx="3">
-            <a:schemeClr val="accent1"/>
-          </a:fillRef>
-          <a:effectRef idx="2">
-            <a:schemeClr val="accent1"/>
-          </a:effectRef>
-          <a:fontRef idx="minor">
-            <a:schemeClr val="lt1"/>
-          </a:fontRef>
-        </p:style>
-        <p:txBody>
-          <a:bodyPr rtlCol="0" anchor="ctr"/>
-          <a:lstStyle/>
-          <a:p>
-            <a:pPr algn="ctr"/>
-            <a:endParaRPr/>
-          </a:p>
-        </p:txBody>
-      </p:sp>
-      <p:sp>
-        <p:nvSpPr>
-          <p:cNvPr id="3" name="TextBox 2"/>
-          <p:cNvSpPr txBox="1"/>
-          <p:nvPr/>
-        </p:nvSpPr>
-        <p:spPr>
-          <a:xfrm>
-            <a:off x="548640" y="502920"/>
-            <a:ext cx="10972800" cy="411480"/>
-          </a:xfrm>
-          <a:prstGeom prst="rect">
-            <a:avLst/>
-          </a:prstGeom>
-          <a:noFill/>
-        </p:spPr>
-        <p:txBody>
-          <a:bodyPr wrap="square" lIns="45720" rIns="45720">
-            <a:spAutoFit/>
-          </a:bodyPr>
-          <a:lstStyle/>
-          <a:p>
-            <a:pPr algn="l"/>
-            <a:r>
-              <a:rPr sz="1400" b="1">
-                <a:solidFill>
-                  <a:srgbClr val="FFC107"/>
-                </a:solidFill>
-                <a:latin typeface="Calibri"/>
-              </a:rPr>
-              <a:t>STATUS &amp; VRAAG</a:t>
-            </a:r>
-          </a:p>
-        </p:txBody>
-      </p:sp>
-      <p:sp>
-        <p:nvSpPr>
-          <p:cNvPr id="4" name="TextBox 3"/>
-          <p:cNvSpPr txBox="1"/>
-          <p:nvPr/>
-        </p:nvSpPr>
-        <p:spPr>
-          <a:xfrm>
-            <a:off x="548640" y="868680"/>
-            <a:ext cx="10972800" cy="868680"/>
-          </a:xfrm>
-          <a:prstGeom prst="rect">
-            <a:avLst/>
-          </a:prstGeom>
-          <a:noFill/>
-        </p:spPr>
-        <p:txBody>
-          <a:bodyPr wrap="square" lIns="45720" rIns="45720">
-            <a:spAutoFit/>
-          </a:bodyPr>
-          <a:lstStyle/>
-          <a:p>
-            <a:pPr algn="l"/>
-            <a:r>
-              <a:rPr sz="3600" b="1">
-                <a:solidFill>
-                  <a:srgbClr val="FFFFFF"/>
-                </a:solidFill>
-                <a:latin typeface="Calibri"/>
-              </a:rPr>
-              <a:t>Productieklaar — klaar voor pilot-deployment</a:t>
-            </a:r>
-          </a:p>
-        </p:txBody>
-      </p:sp>
-      <p:sp>
-        <p:nvSpPr>
-          <p:cNvPr id="5" name="Rounded Rectangle 4"/>
-          <p:cNvSpPr/>
-          <p:nvPr/>
-        </p:nvSpPr>
-        <p:spPr>
-          <a:xfrm>
-            <a:off x="548640" y="2194560"/>
-            <a:ext cx="2560320" cy="1828800"/>
-          </a:xfrm>
-          <a:prstGeom prst="roundRect">
-            <a:avLst/>
-          </a:prstGeom>
-          <a:solidFill>
-            <a:srgbClr val="4A5D23"/>
-          </a:solidFill>
-          <a:ln>
-            <a:solidFill>
-              <a:srgbClr val="FFC107"/>
-            </a:solidFill>
-          </a:ln>
-        </p:spPr>
-        <p:style>
-          <a:lnRef idx="1">
-            <a:schemeClr val="accent1"/>
-          </a:lnRef>
-          <a:fillRef idx="3">
-            <a:schemeClr val="accent1"/>
-          </a:fillRef>
-          <a:effectRef idx="2">
-            <a:schemeClr val="accent1"/>
-          </a:effectRef>
-          <a:fontRef idx="minor">
-            <a:schemeClr val="lt1"/>
-          </a:fontRef>
-        </p:style>
-        <p:txBody>
-          <a:bodyPr rtlCol="0" anchor="ctr"/>
-          <a:lstStyle/>
-          <a:p>
-            <a:pPr algn="ctr"/>
-            <a:endParaRPr/>
-          </a:p>
-        </p:txBody>
-      </p:sp>
-      <p:sp>
-        <p:nvSpPr>
-          <p:cNvPr id="6" name="TextBox 5"/>
-          <p:cNvSpPr txBox="1"/>
-          <p:nvPr/>
-        </p:nvSpPr>
-        <p:spPr>
-          <a:xfrm>
-            <a:off x="548640" y="2468880"/>
-            <a:ext cx="2560320" cy="822960"/>
-          </a:xfrm>
-          <a:prstGeom prst="rect">
-            <a:avLst/>
-          </a:prstGeom>
-          <a:noFill/>
-        </p:spPr>
-        <p:txBody>
-          <a:bodyPr wrap="square" lIns="45720" rIns="45720">
-            <a:spAutoFit/>
-          </a:bodyPr>
-          <a:lstStyle/>
-          <a:p>
-            <a:pPr algn="ctr"/>
-            <a:r>
-              <a:rPr sz="4000" b="1">
-                <a:solidFill>
-                  <a:srgbClr val="FFC107"/>
-                </a:solidFill>
-                <a:latin typeface="Calibri"/>
-              </a:rPr>
-              <a:t>171</a:t>
-            </a:r>
-          </a:p>
-        </p:txBody>
-      </p:sp>
-      <p:sp>
-        <p:nvSpPr>
-          <p:cNvPr id="7" name="TextBox 6"/>
-          <p:cNvSpPr txBox="1"/>
-          <p:nvPr/>
-        </p:nvSpPr>
-        <p:spPr>
-          <a:xfrm>
-            <a:off x="548640" y="3383280"/>
-            <a:ext cx="2560320" cy="457200"/>
-          </a:xfrm>
-          <a:prstGeom prst="rect">
-            <a:avLst/>
-          </a:prstGeom>
-          <a:noFill/>
-        </p:spPr>
-        <p:txBody>
-          <a:bodyPr wrap="square" lIns="45720" rIns="45720">
-            <a:spAutoFit/>
-          </a:bodyPr>
-          <a:lstStyle/>
-          <a:p>
-            <a:pPr algn="ctr"/>
-            <a:r>
-              <a:rPr sz="1200" b="0">
-                <a:solidFill>
-                  <a:srgbClr val="F5F1E6"/>
-                </a:solidFill>
-                <a:latin typeface="Calibri"/>
-              </a:rPr>
-              <a:t>tests groen</a:t>
-            </a:r>
-          </a:p>
-        </p:txBody>
-      </p:sp>
-      <p:sp>
-        <p:nvSpPr>
-          <p:cNvPr id="8" name="Rounded Rectangle 7"/>
-          <p:cNvSpPr/>
-          <p:nvPr/>
-        </p:nvSpPr>
-        <p:spPr>
-          <a:xfrm>
-            <a:off x="3291840" y="2194560"/>
-            <a:ext cx="2560320" cy="1828800"/>
-          </a:xfrm>
-          <a:prstGeom prst="roundRect">
-            <a:avLst/>
-          </a:prstGeom>
-          <a:solidFill>
-            <a:srgbClr val="4A5D23"/>
-          </a:solidFill>
-          <a:ln>
-            <a:solidFill>
-              <a:srgbClr val="FFC107"/>
-            </a:solidFill>
-          </a:ln>
-        </p:spPr>
-        <p:style>
-          <a:lnRef idx="1">
-            <a:schemeClr val="accent1"/>
-          </a:lnRef>
-          <a:fillRef idx="3">
-            <a:schemeClr val="accent1"/>
-          </a:fillRef>
-          <a:effectRef idx="2">
-            <a:schemeClr val="accent1"/>
-          </a:effectRef>
-          <a:fontRef idx="minor">
-            <a:schemeClr val="lt1"/>
-          </a:fontRef>
-        </p:style>
-        <p:txBody>
-          <a:bodyPr rtlCol="0" anchor="ctr"/>
-          <a:lstStyle/>
-          <a:p>
-            <a:pPr algn="ctr"/>
-            <a:endParaRPr/>
-          </a:p>
-        </p:txBody>
-      </p:sp>
-      <p:sp>
-        <p:nvSpPr>
-          <p:cNvPr id="9" name="TextBox 8"/>
-          <p:cNvSpPr txBox="1"/>
-          <p:nvPr/>
-        </p:nvSpPr>
-        <p:spPr>
-          <a:xfrm>
-            <a:off x="3291840" y="2468880"/>
-            <a:ext cx="2560320" cy="822960"/>
-          </a:xfrm>
-          <a:prstGeom prst="rect">
-            <a:avLst/>
-          </a:prstGeom>
-          <a:noFill/>
-        </p:spPr>
-        <p:txBody>
-          <a:bodyPr wrap="square" lIns="45720" rIns="45720">
-            <a:spAutoFit/>
-          </a:bodyPr>
-          <a:lstStyle/>
-          <a:p>
-            <a:pPr algn="ctr"/>
-            <a:r>
-              <a:rPr sz="4000" b="1">
-                <a:solidFill>
-                  <a:srgbClr val="FFC107"/>
-                </a:solidFill>
-                <a:latin typeface="Calibri"/>
-              </a:rPr>
-              <a:t>94 / 94</a:t>
-            </a:r>
-          </a:p>
-        </p:txBody>
-      </p:sp>
-      <p:sp>
-        <p:nvSpPr>
-          <p:cNvPr id="10" name="TextBox 9"/>
-          <p:cNvSpPr txBox="1"/>
-          <p:nvPr/>
-        </p:nvSpPr>
-        <p:spPr>
-          <a:xfrm>
-            <a:off x="3291840" y="3383280"/>
-            <a:ext cx="2560320" cy="457200"/>
-          </a:xfrm>
-          <a:prstGeom prst="rect">
-            <a:avLst/>
-          </a:prstGeom>
-          <a:noFill/>
-        </p:spPr>
-        <p:txBody>
-          <a:bodyPr wrap="square" lIns="45720" rIns="45720">
-            <a:spAutoFit/>
-          </a:bodyPr>
-          <a:lstStyle/>
-          <a:p>
-            <a:pPr algn="ctr"/>
-            <a:r>
-              <a:rPr sz="1200" b="0">
-                <a:solidFill>
-                  <a:srgbClr val="F5F1E6"/>
-                </a:solidFill>
-                <a:latin typeface="Calibri"/>
-              </a:rPr>
-              <a:t>stories klaar</a:t>
-            </a:r>
-          </a:p>
-        </p:txBody>
-      </p:sp>
-      <p:sp>
-        <p:nvSpPr>
-          <p:cNvPr id="11" name="Rounded Rectangle 10"/>
-          <p:cNvSpPr/>
-          <p:nvPr/>
-        </p:nvSpPr>
-        <p:spPr>
-          <a:xfrm>
-            <a:off x="6035040" y="2194560"/>
-            <a:ext cx="2560320" cy="1828800"/>
-          </a:xfrm>
-          <a:prstGeom prst="roundRect">
-            <a:avLst/>
-          </a:prstGeom>
-          <a:solidFill>
-            <a:srgbClr val="4A5D23"/>
-          </a:solidFill>
-          <a:ln>
-            <a:solidFill>
-              <a:srgbClr val="FFC107"/>
-            </a:solidFill>
-          </a:ln>
-        </p:spPr>
-        <p:style>
-          <a:lnRef idx="1">
-            <a:schemeClr val="accent1"/>
-          </a:lnRef>
-          <a:fillRef idx="3">
-            <a:schemeClr val="accent1"/>
-          </a:fillRef>
-          <a:effectRef idx="2">
-            <a:schemeClr val="accent1"/>
-          </a:effectRef>
-          <a:fontRef idx="minor">
-            <a:schemeClr val="lt1"/>
-          </a:fontRef>
-        </p:style>
-        <p:txBody>
-          <a:bodyPr rtlCol="0" anchor="ctr"/>
-          <a:lstStyle/>
-          <a:p>
-            <a:pPr algn="ctr"/>
-            <a:endParaRPr/>
-          </a:p>
-        </p:txBody>
-      </p:sp>
-      <p:sp>
-        <p:nvSpPr>
-          <p:cNvPr id="12" name="TextBox 11"/>
-          <p:cNvSpPr txBox="1"/>
-          <p:nvPr/>
-        </p:nvSpPr>
-        <p:spPr>
-          <a:xfrm>
-            <a:off x="6035040" y="2468880"/>
-            <a:ext cx="2560320" cy="822960"/>
-          </a:xfrm>
-          <a:prstGeom prst="rect">
-            <a:avLst/>
-          </a:prstGeom>
-          <a:noFill/>
-        </p:spPr>
-        <p:txBody>
-          <a:bodyPr wrap="square" lIns="45720" rIns="45720">
-            <a:spAutoFit/>
-          </a:bodyPr>
-          <a:lstStyle/>
-          <a:p>
-            <a:pPr algn="ctr"/>
-            <a:r>
-              <a:rPr sz="4000" b="1">
-                <a:solidFill>
-                  <a:srgbClr val="FFC107"/>
-                </a:solidFill>
-                <a:latin typeface="Calibri"/>
-              </a:rPr>
-              <a:t>EN/NL/FR</a:t>
-            </a:r>
-          </a:p>
-        </p:txBody>
-      </p:sp>
-      <p:sp>
-        <p:nvSpPr>
-          <p:cNvPr id="13" name="TextBox 12"/>
-          <p:cNvSpPr txBox="1"/>
-          <p:nvPr/>
-        </p:nvSpPr>
-        <p:spPr>
-          <a:xfrm>
-            <a:off x="6035040" y="3383280"/>
-            <a:ext cx="2560320" cy="457200"/>
-          </a:xfrm>
-          <a:prstGeom prst="rect">
-            <a:avLst/>
-          </a:prstGeom>
-          <a:noFill/>
-        </p:spPr>
-        <p:txBody>
-          <a:bodyPr wrap="square" lIns="45720" rIns="45720">
-            <a:spAutoFit/>
-          </a:bodyPr>
-          <a:lstStyle/>
-          <a:p>
-            <a:pPr algn="ctr"/>
-            <a:r>
-              <a:rPr sz="1200" b="0">
-                <a:solidFill>
-                  <a:srgbClr val="F5F1E6"/>
-                </a:solidFill>
-                <a:latin typeface="Calibri"/>
-              </a:rPr>
-              <a:t>i18n compleet</a:t>
-            </a:r>
-          </a:p>
-        </p:txBody>
-      </p:sp>
-      <p:sp>
-        <p:nvSpPr>
-          <p:cNvPr id="14" name="Rounded Rectangle 13"/>
-          <p:cNvSpPr/>
-          <p:nvPr/>
-        </p:nvSpPr>
-        <p:spPr>
-          <a:xfrm>
-            <a:off x="8778240" y="2194560"/>
-            <a:ext cx="2560320" cy="1828800"/>
-          </a:xfrm>
-          <a:prstGeom prst="roundRect">
-            <a:avLst/>
-          </a:prstGeom>
-          <a:solidFill>
-            <a:srgbClr val="4A5D23"/>
-          </a:solidFill>
-          <a:ln>
-            <a:solidFill>
-              <a:srgbClr val="FFC107"/>
-            </a:solidFill>
-          </a:ln>
-        </p:spPr>
-        <p:style>
-          <a:lnRef idx="1">
-            <a:schemeClr val="accent1"/>
-          </a:lnRef>
-          <a:fillRef idx="3">
-            <a:schemeClr val="accent1"/>
-          </a:fillRef>
-          <a:effectRef idx="2">
-            <a:schemeClr val="accent1"/>
-          </a:effectRef>
-          <a:fontRef idx="minor">
-            <a:schemeClr val="lt1"/>
-          </a:fontRef>
-        </p:style>
-        <p:txBody>
-          <a:bodyPr rtlCol="0" anchor="ctr"/>
-          <a:lstStyle/>
-          <a:p>
-            <a:pPr algn="ctr"/>
-            <a:endParaRPr/>
-          </a:p>
-        </p:txBody>
-      </p:sp>
-      <p:sp>
-        <p:nvSpPr>
-          <p:cNvPr id="15" name="TextBox 14"/>
-          <p:cNvSpPr txBox="1"/>
-          <p:nvPr/>
-        </p:nvSpPr>
-        <p:spPr>
-          <a:xfrm>
-            <a:off x="8778240" y="2468880"/>
-            <a:ext cx="2560320" cy="822960"/>
-          </a:xfrm>
-          <a:prstGeom prst="rect">
-            <a:avLst/>
-          </a:prstGeom>
-          <a:noFill/>
-        </p:spPr>
-        <p:txBody>
-          <a:bodyPr wrap="square" lIns="45720" rIns="45720">
-            <a:spAutoFit/>
-          </a:bodyPr>
-          <a:lstStyle/>
-          <a:p>
-            <a:pPr algn="ctr"/>
-            <a:r>
-              <a:rPr sz="4000" b="1">
-                <a:solidFill>
-                  <a:srgbClr val="FFC107"/>
-                </a:solidFill>
-                <a:latin typeface="Calibri"/>
-              </a:rPr>
-              <a:t>AVG ✓</a:t>
-            </a:r>
-          </a:p>
-        </p:txBody>
-      </p:sp>
-      <p:sp>
-        <p:nvSpPr>
-          <p:cNvPr id="16" name="TextBox 15"/>
-          <p:cNvSpPr txBox="1"/>
-          <p:nvPr/>
-        </p:nvSpPr>
-        <p:spPr>
-          <a:xfrm>
-            <a:off x="8778240" y="3383280"/>
-            <a:ext cx="2560320" cy="457200"/>
-          </a:xfrm>
-          <a:prstGeom prst="rect">
-            <a:avLst/>
-          </a:prstGeom>
-          <a:noFill/>
-        </p:spPr>
-        <p:txBody>
-          <a:bodyPr wrap="square" lIns="45720" rIns="45720">
-            <a:spAutoFit/>
-          </a:bodyPr>
-          <a:lstStyle/>
-          <a:p>
-            <a:pPr algn="ctr"/>
-            <a:r>
-              <a:rPr sz="1200" b="0">
-                <a:solidFill>
-                  <a:srgbClr val="F5F1E6"/>
-                </a:solidFill>
-                <a:latin typeface="Calibri"/>
-              </a:rPr>
-              <a:t>GDPR compliant</a:t>
-            </a:r>
-          </a:p>
-        </p:txBody>
-      </p:sp>
-      <p:sp>
-        <p:nvSpPr>
-          <p:cNvPr id="17" name="TextBox 16"/>
-          <p:cNvSpPr txBox="1"/>
-          <p:nvPr/>
-        </p:nvSpPr>
-        <p:spPr>
-          <a:xfrm>
-            <a:off x="548640" y="4389120"/>
-            <a:ext cx="10972800" cy="457200"/>
-          </a:xfrm>
-          <a:prstGeom prst="rect">
-            <a:avLst/>
-          </a:prstGeom>
-          <a:noFill/>
-        </p:spPr>
-        <p:txBody>
-          <a:bodyPr wrap="square" lIns="45720" rIns="45720">
-            <a:spAutoFit/>
-          </a:bodyPr>
-          <a:lstStyle/>
-          <a:p>
-            <a:pPr algn="l"/>
-            <a:r>
-              <a:rPr sz="1400" b="1">
-                <a:solidFill>
-                  <a:srgbClr val="FFC107"/>
-                </a:solidFill>
-                <a:latin typeface="Calibri"/>
-              </a:rPr>
-              <a:t>DE VRAAG</a:t>
-            </a:r>
-          </a:p>
-        </p:txBody>
-      </p:sp>
-      <p:sp>
-        <p:nvSpPr>
-          <p:cNvPr id="18" name="TextBox 17"/>
-          <p:cNvSpPr txBox="1"/>
-          <p:nvPr/>
-        </p:nvSpPr>
-        <p:spPr>
-          <a:xfrm>
-            <a:off x="548640" y="4754880"/>
-            <a:ext cx="10972800" cy="1645920"/>
-          </a:xfrm>
-          <a:prstGeom prst="rect">
-            <a:avLst/>
-          </a:prstGeom>
-          <a:noFill/>
-        </p:spPr>
-        <p:txBody>
-          <a:bodyPr wrap="square" lIns="45720" rIns="45720">
-            <a:spAutoFit/>
-          </a:bodyPr>
-          <a:lstStyle/>
-          <a:p>
-            <a:pPr algn="l"/>
-            <a:r>
-              <a:rPr sz="2000" b="0">
-                <a:solidFill>
-                  <a:srgbClr val="FFFFFF"/>
-                </a:solidFill>
-                <a:latin typeface="Calibri"/>
-              </a:rPr>
-              <a:t>→  Pilot-deployment in één SOR-eenheid (Q3 2026)</a:t>
-            </a:r>
-          </a:p>
-          <a:p>
-            <a:pPr algn="l"/>
-            <a:r>
-              <a:rPr sz="2000" b="0">
-                <a:solidFill>
-                  <a:srgbClr val="FFFFFF"/>
-                </a:solidFill>
-                <a:latin typeface="Calibri"/>
-              </a:rPr>
-              <a:t>→  Toegang tot BEMIL-API voor productie-koppeling</a:t>
-            </a:r>
-          </a:p>
-          <a:p>
-            <a:pPr algn="l"/>
-            <a:r>
-              <a:rPr sz="2000" b="0">
-                <a:solidFill>
-                  <a:srgbClr val="FFFFFF"/>
-                </a:solidFill>
-                <a:latin typeface="Calibri"/>
-              </a:rPr>
-              <a:t>→  Feedback van PTI's tijdens MFFT-rollout 2026</a:t>
-            </a:r>
-          </a:p>
-        </p:txBody>
-      </p:sp>
-      <p:sp>
-        <p:nvSpPr>
-          <p:cNvPr id="19" name="TextBox 18"/>
-          <p:cNvSpPr txBox="1"/>
-          <p:nvPr/>
-        </p:nvSpPr>
-        <p:spPr>
-          <a:xfrm>
-            <a:off x="548640" y="6446520"/>
-            <a:ext cx="10972800" cy="365760"/>
-          </a:xfrm>
-          <a:prstGeom prst="rect">
-            <a:avLst/>
-          </a:prstGeom>
-          <a:noFill/>
-        </p:spPr>
-        <p:txBody>
-          <a:bodyPr wrap="square" lIns="45720" rIns="45720">
-            <a:spAutoFit/>
-          </a:bodyPr>
-          <a:lstStyle/>
-          <a:p>
-            <a:pPr algn="l"/>
-            <a:r>
-              <a:rPr sz="1100" b="0">
-                <a:solidFill>
-                  <a:srgbClr val="C3B091"/>
-                </a:solidFill>
-                <a:latin typeface="Calibri"/>
-              </a:rPr>
-              <a:t>benoit.goethals@gmail.com  ·  github.com/BenoitGoethals/WarriorFit</a:t>
-            </a:r>
-          </a:p>
-        </p:txBody>
-      </p:sp>
-    </p:spTree>
-  </p:cSld>
-  <p:clrMapOvr>
-    <a:masterClrMapping/>
-  </p:clrMapOvr>
-</p:sld>
-</file>
-
 <file path=ppt/slides/slide2.xml><?xml version="1.0" encoding="utf-8"?>
 <p:sld xmlns:a="http://schemas.openxmlformats.org/drawingml/2006/main" xmlns:r="http://schemas.openxmlformats.org/officeDocument/2006/relationships" xmlns:p="http://schemas.openxmlformats.org/presentationml/2006/main">
   <p:cSld>
@@ -7722,13 +6988,103 @@
           <a:p>
             <a:pPr algn="ctr"/>
             <a:r>
-              <a:rPr sz="1400" b="0">
+              <a:rPr sz="1400" b="0" dirty="0">
                 <a:solidFill>
                   <a:srgbClr val="555555"/>
                 </a:solidFill>
                 <a:latin typeface="Calibri"/>
               </a:rPr>
-              <a:t>Per eenheid: ~500 militairen × 5 testtypes × 1× per jaar = 2 500 testresultaten per unit</a:t>
+              <a:t>Per </a:t>
+            </a:r>
+            <a:r>
+              <a:rPr sz="1400" b="0" dirty="0" err="1">
+                <a:solidFill>
+                  <a:srgbClr val="555555"/>
+                </a:solidFill>
+                <a:latin typeface="Calibri"/>
+              </a:rPr>
+              <a:t>eenheid</a:t>
+            </a:r>
+            <a:r>
+              <a:rPr sz="1400" b="0" dirty="0">
+                <a:solidFill>
+                  <a:srgbClr val="555555"/>
+                </a:solidFill>
+                <a:latin typeface="Calibri"/>
+              </a:rPr>
+              <a:t>: ~500 </a:t>
+            </a:r>
+            <a:r>
+              <a:rPr sz="1400" b="0" dirty="0" err="1">
+                <a:solidFill>
+                  <a:srgbClr val="555555"/>
+                </a:solidFill>
+                <a:latin typeface="Calibri"/>
+              </a:rPr>
+              <a:t>militairen</a:t>
+            </a:r>
+            <a:r>
+              <a:rPr sz="1400" b="0" dirty="0">
+                <a:solidFill>
+                  <a:srgbClr val="555555"/>
+                </a:solidFill>
+                <a:latin typeface="Calibri"/>
+              </a:rPr>
+              <a:t> × 5 </a:t>
+            </a:r>
+            <a:r>
+              <a:rPr sz="1400" b="0" dirty="0" err="1">
+                <a:solidFill>
+                  <a:srgbClr val="555555"/>
+                </a:solidFill>
+                <a:latin typeface="Calibri"/>
+              </a:rPr>
+              <a:t>testtypes</a:t>
+            </a:r>
+            <a:r>
+              <a:rPr sz="1400" b="0" dirty="0">
+                <a:solidFill>
+                  <a:srgbClr val="555555"/>
+                </a:solidFill>
+                <a:latin typeface="Calibri"/>
+              </a:rPr>
+              <a:t> × 1× per </a:t>
+            </a:r>
+            <a:r>
+              <a:rPr sz="1400" b="0" dirty="0" err="1">
+                <a:solidFill>
+                  <a:srgbClr val="555555"/>
+                </a:solidFill>
+                <a:latin typeface="Calibri"/>
+              </a:rPr>
+              <a:t>jaar</a:t>
+            </a:r>
+            <a:r>
+              <a:rPr sz="1400" b="0" dirty="0">
+                <a:solidFill>
+                  <a:srgbClr val="555555"/>
+                </a:solidFill>
+                <a:latin typeface="Calibri"/>
+              </a:rPr>
+              <a:t> = 2 500 </a:t>
+            </a:r>
+            <a:r>
+              <a:rPr sz="1400" b="0" dirty="0" err="1">
+                <a:solidFill>
+                  <a:srgbClr val="555555"/>
+                </a:solidFill>
+                <a:latin typeface="Calibri"/>
+              </a:rPr>
+              <a:t>testresultaten</a:t>
+            </a:r>
+            <a:r>
+              <a:rPr sz="1400" b="0" dirty="0">
+                <a:solidFill>
+                  <a:srgbClr val="555555"/>
+                </a:solidFill>
+                <a:latin typeface="Calibri"/>
+              </a:rPr>
+              <a:t> per unit</a:t>
             </a:r>
           </a:p>
         </p:txBody>
@@ -12849,7 +12205,7 @@
             <a:avLst/>
           </a:prstGeom>
           <a:solidFill>
-            <a:srgbClr val="F5F1E6"/>
+            <a:srgbClr val="334218"/>
           </a:solidFill>
           <a:ln>
             <a:noFill/>
@@ -12881,45 +12237,36 @@
       </p:sp>
       <p:sp>
         <p:nvSpPr>
-          <p:cNvPr id="3" name="Rectangle 2"/>
-          <p:cNvSpPr/>
-          <p:nvPr/>
-        </p:nvSpPr>
-        <p:spPr>
-          <a:xfrm>
-            <a:off x="0" y="0"/>
-            <a:ext cx="12191695" cy="164592"/>
-          </a:xfrm>
-          <a:prstGeom prst="rect">
-            <a:avLst/>
-          </a:prstGeom>
-          <a:solidFill>
-            <a:srgbClr val="4A5D23"/>
-          </a:solidFill>
-          <a:ln>
-            <a:noFill/>
-          </a:ln>
-        </p:spPr>
-        <p:style>
-          <a:lnRef idx="1">
-            <a:schemeClr val="accent1"/>
-          </a:lnRef>
-          <a:fillRef idx="3">
-            <a:schemeClr val="accent1"/>
-          </a:fillRef>
-          <a:effectRef idx="2">
-            <a:schemeClr val="accent1"/>
-          </a:effectRef>
-          <a:fontRef idx="minor">
-            <a:schemeClr val="lt1"/>
-          </a:fontRef>
-        </p:style>
-        <p:txBody>
-          <a:bodyPr rtlCol="0" anchor="ctr"/>
-          <a:lstStyle/>
-          <a:p>
-            <a:pPr algn="ctr"/>
-            <a:endParaRPr/>
+          <p:cNvPr id="3" name="TextBox 2"/>
+          <p:cNvSpPr txBox="1"/>
+          <p:nvPr/>
+        </p:nvSpPr>
+        <p:spPr>
+          <a:xfrm>
+            <a:off x="548640" y="502920"/>
+            <a:ext cx="10972800" cy="411480"/>
+          </a:xfrm>
+          <a:prstGeom prst="rect">
+            <a:avLst/>
+          </a:prstGeom>
+          <a:noFill/>
+        </p:spPr>
+        <p:txBody>
+          <a:bodyPr wrap="square" lIns="45720" rIns="45720">
+            <a:spAutoFit/>
+          </a:bodyPr>
+          <a:lstStyle/>
+          <a:p>
+            <a:pPr algn="l"/>
+            <a:r>
+              <a:rPr sz="1400" b="1">
+                <a:solidFill>
+                  <a:srgbClr val="FFC107"/>
+                </a:solidFill>
+                <a:latin typeface="Calibri"/>
+              </a:rPr>
+              <a:t>STATUS &amp; VRAAG</a:t>
+            </a:r>
           </a:p>
         </p:txBody>
       </p:sp>
@@ -12931,8 +12278,8 @@
         </p:nvSpPr>
         <p:spPr>
           <a:xfrm>
-            <a:off x="548640" y="502920"/>
-            <a:ext cx="10972800" cy="411480"/>
+            <a:off x="548640" y="868680"/>
+            <a:ext cx="10972800" cy="868680"/>
           </a:xfrm>
           <a:prstGeom prst="rect">
             <a:avLst/>
@@ -12947,110 +12294,29 @@
           <a:p>
             <a:pPr algn="l"/>
             <a:r>
-              <a:rPr sz="1400" b="1">
-                <a:solidFill>
-                  <a:srgbClr val="FFC107"/>
-                </a:solidFill>
-                <a:latin typeface="Calibri"/>
-              </a:rPr>
-              <a:t>TEAM</a:t>
-            </a:r>
-          </a:p>
-        </p:txBody>
-      </p:sp>
-      <p:sp>
-        <p:nvSpPr>
-          <p:cNvPr id="5" name="TextBox 4"/>
-          <p:cNvSpPr txBox="1"/>
-          <p:nvPr/>
-        </p:nvSpPr>
-        <p:spPr>
-          <a:xfrm>
-            <a:off x="548640" y="868680"/>
-            <a:ext cx="10972800" cy="868680"/>
-          </a:xfrm>
-          <a:prstGeom prst="rect">
-            <a:avLst/>
-          </a:prstGeom>
-          <a:noFill/>
-        </p:spPr>
-        <p:txBody>
-          <a:bodyPr wrap="square" lIns="45720" rIns="45720">
-            <a:spAutoFit/>
-          </a:bodyPr>
-          <a:lstStyle/>
-          <a:p>
-            <a:pPr algn="l"/>
-            <a:r>
               <a:rPr sz="3600" b="1">
                 <a:solidFill>
-                  <a:srgbClr val="222222"/>
-                </a:solidFill>
-                <a:latin typeface="Calibri"/>
-              </a:rPr>
-              <a:t>Eénpersoonsproject met militaire achtergrond</a:t>
-            </a:r>
-          </a:p>
-        </p:txBody>
-      </p:sp>
-      <p:sp>
-        <p:nvSpPr>
-          <p:cNvPr id="6" name="Rounded Rectangle 5"/>
+                  <a:srgbClr val="FFFFFF"/>
+                </a:solidFill>
+                <a:latin typeface="Calibri"/>
+              </a:rPr>
+              <a:t>Productieklaar — klaar voor pilot-deployment</a:t>
+            </a:r>
+          </a:p>
+        </p:txBody>
+      </p:sp>
+      <p:sp>
+        <p:nvSpPr>
+          <p:cNvPr id="5" name="Rounded Rectangle 4"/>
           <p:cNvSpPr/>
           <p:nvPr/>
         </p:nvSpPr>
         <p:spPr>
           <a:xfrm>
             <a:off x="548640" y="2194560"/>
-            <a:ext cx="11064240" cy="4023360"/>
+            <a:ext cx="2560320" cy="1828800"/>
           </a:xfrm>
           <a:prstGeom prst="roundRect">
-            <a:avLst/>
-          </a:prstGeom>
-          <a:solidFill>
-            <a:srgbClr val="FFFFFF"/>
-          </a:solidFill>
-          <a:ln>
-            <a:solidFill>
-              <a:srgbClr val="C3B091"/>
-            </a:solidFill>
-          </a:ln>
-        </p:spPr>
-        <p:style>
-          <a:lnRef idx="1">
-            <a:schemeClr val="accent1"/>
-          </a:lnRef>
-          <a:fillRef idx="3">
-            <a:schemeClr val="accent1"/>
-          </a:fillRef>
-          <a:effectRef idx="2">
-            <a:schemeClr val="accent1"/>
-          </a:effectRef>
-          <a:fontRef idx="minor">
-            <a:schemeClr val="lt1"/>
-          </a:fontRef>
-        </p:style>
-        <p:txBody>
-          <a:bodyPr rtlCol="0" anchor="ctr"/>
-          <a:lstStyle/>
-          <a:p>
-            <a:pPr algn="ctr"/>
-            <a:endParaRPr/>
-          </a:p>
-        </p:txBody>
-      </p:sp>
-      <p:sp>
-        <p:nvSpPr>
-          <p:cNvPr id="7" name="Oval 6"/>
-          <p:cNvSpPr/>
-          <p:nvPr/>
-        </p:nvSpPr>
-        <p:spPr>
-          <a:xfrm>
-            <a:off x="914400" y="2560320"/>
-            <a:ext cx="2194560" cy="2194560"/>
-          </a:xfrm>
-          <a:prstGeom prst="ellipse">
             <a:avLst/>
           </a:prstGeom>
           <a:solidFill>
@@ -13087,14 +12353,14 @@
       </p:sp>
       <p:sp>
         <p:nvSpPr>
-          <p:cNvPr id="8" name="TextBox 7"/>
+          <p:cNvPr id="6" name="TextBox 5"/>
           <p:cNvSpPr txBox="1"/>
           <p:nvPr/>
         </p:nvSpPr>
         <p:spPr>
           <a:xfrm>
-            <a:off x="914400" y="3200400"/>
-            <a:ext cx="2194560" cy="914400"/>
+            <a:off x="548640" y="2468880"/>
+            <a:ext cx="2560320" cy="822960"/>
           </a:xfrm>
           <a:prstGeom prst="rect">
             <a:avLst/>
@@ -13109,14 +12375,95 @@
           <a:p>
             <a:pPr algn="ctr"/>
             <a:r>
-              <a:rPr sz="6000" b="1">
+              <a:rPr sz="4000" b="1">
                 <a:solidFill>
                   <a:srgbClr val="FFC107"/>
                 </a:solidFill>
                 <a:latin typeface="Calibri"/>
               </a:rPr>
-              <a:t>BG</a:t>
-            </a:r>
+              <a:t>171</a:t>
+            </a:r>
+          </a:p>
+        </p:txBody>
+      </p:sp>
+      <p:sp>
+        <p:nvSpPr>
+          <p:cNvPr id="7" name="TextBox 6"/>
+          <p:cNvSpPr txBox="1"/>
+          <p:nvPr/>
+        </p:nvSpPr>
+        <p:spPr>
+          <a:xfrm>
+            <a:off x="548640" y="3383280"/>
+            <a:ext cx="2560320" cy="457200"/>
+          </a:xfrm>
+          <a:prstGeom prst="rect">
+            <a:avLst/>
+          </a:prstGeom>
+          <a:noFill/>
+        </p:spPr>
+        <p:txBody>
+          <a:bodyPr wrap="square" lIns="45720" rIns="45720">
+            <a:spAutoFit/>
+          </a:bodyPr>
+          <a:lstStyle/>
+          <a:p>
+            <a:pPr algn="ctr"/>
+            <a:r>
+              <a:rPr sz="1200" b="0">
+                <a:solidFill>
+                  <a:srgbClr val="F5F1E6"/>
+                </a:solidFill>
+                <a:latin typeface="Calibri"/>
+              </a:rPr>
+              <a:t>tests groen</a:t>
+            </a:r>
+          </a:p>
+        </p:txBody>
+      </p:sp>
+      <p:sp>
+        <p:nvSpPr>
+          <p:cNvPr id="8" name="Rounded Rectangle 7"/>
+          <p:cNvSpPr/>
+          <p:nvPr/>
+        </p:nvSpPr>
+        <p:spPr>
+          <a:xfrm>
+            <a:off x="3291840" y="2194560"/>
+            <a:ext cx="2560320" cy="1828800"/>
+          </a:xfrm>
+          <a:prstGeom prst="roundRect">
+            <a:avLst/>
+          </a:prstGeom>
+          <a:solidFill>
+            <a:srgbClr val="4A5D23"/>
+          </a:solidFill>
+          <a:ln>
+            <a:solidFill>
+              <a:srgbClr val="FFC107"/>
+            </a:solidFill>
+          </a:ln>
+        </p:spPr>
+        <p:style>
+          <a:lnRef idx="1">
+            <a:schemeClr val="accent1"/>
+          </a:lnRef>
+          <a:fillRef idx="3">
+            <a:schemeClr val="accent1"/>
+          </a:fillRef>
+          <a:effectRef idx="2">
+            <a:schemeClr val="accent1"/>
+          </a:effectRef>
+          <a:fontRef idx="minor">
+            <a:schemeClr val="lt1"/>
+          </a:fontRef>
+        </p:style>
+        <p:txBody>
+          <a:bodyPr rtlCol="0" anchor="ctr"/>
+          <a:lstStyle/>
+          <a:p>
+            <a:pPr algn="ctr"/>
+            <a:endParaRPr/>
           </a:p>
         </p:txBody>
       </p:sp>
@@ -13128,8 +12475,8 @@
         </p:nvSpPr>
         <p:spPr>
           <a:xfrm>
-            <a:off x="3474720" y="2468880"/>
-            <a:ext cx="8229600" cy="548640"/>
+            <a:off x="3291840" y="2468880"/>
+            <a:ext cx="2560320" cy="822960"/>
           </a:xfrm>
           <a:prstGeom prst="rect">
             <a:avLst/>
@@ -13142,15 +12489,15 @@
           </a:bodyPr>
           <a:lstStyle/>
           <a:p>
-            <a:pPr algn="l"/>
-            <a:r>
-              <a:rPr sz="2600" b="1">
-                <a:solidFill>
-                  <a:srgbClr val="222222"/>
-                </a:solidFill>
-                <a:latin typeface="Calibri"/>
-              </a:rPr>
-              <a:t>Benoit Goethals</a:t>
+            <a:pPr algn="ctr"/>
+            <a:r>
+              <a:rPr sz="4000" b="1">
+                <a:solidFill>
+                  <a:srgbClr val="FFC107"/>
+                </a:solidFill>
+                <a:latin typeface="Calibri"/>
+              </a:rPr>
+              <a:t>94 / 94</a:t>
             </a:r>
           </a:p>
         </p:txBody>
@@ -13163,8 +12510,8 @@
         </p:nvSpPr>
         <p:spPr>
           <a:xfrm>
-            <a:off x="3474720" y="3017520"/>
-            <a:ext cx="8229600" cy="457200"/>
+            <a:off x="3291840" y="3383280"/>
+            <a:ext cx="2560320" cy="457200"/>
           </a:xfrm>
           <a:prstGeom prst="rect">
             <a:avLst/>
@@ -13177,29 +12524,75 @@
           </a:bodyPr>
           <a:lstStyle/>
           <a:p>
-            <a:pPr algn="l"/>
-            <a:r>
-              <a:rPr sz="1500" b="0">
-                <a:solidFill>
-                  <a:srgbClr val="4A5D23"/>
-                </a:solidFill>
-                <a:latin typeface="Calibri"/>
-              </a:rPr>
-              <a:t>Solo developer · architect · product owner</a:t>
-            </a:r>
-          </a:p>
-        </p:txBody>
-      </p:sp>
-      <p:sp>
-        <p:nvSpPr>
-          <p:cNvPr id="11" name="TextBox 10"/>
+            <a:pPr algn="ctr"/>
+            <a:r>
+              <a:rPr sz="1200" b="0">
+                <a:solidFill>
+                  <a:srgbClr val="F5F1E6"/>
+                </a:solidFill>
+                <a:latin typeface="Calibri"/>
+              </a:rPr>
+              <a:t>stories klaar</a:t>
+            </a:r>
+          </a:p>
+        </p:txBody>
+      </p:sp>
+      <p:sp>
+        <p:nvSpPr>
+          <p:cNvPr id="11" name="Rounded Rectangle 10"/>
+          <p:cNvSpPr/>
+          <p:nvPr/>
+        </p:nvSpPr>
+        <p:spPr>
+          <a:xfrm>
+            <a:off x="6035040" y="2194560"/>
+            <a:ext cx="2560320" cy="1828800"/>
+          </a:xfrm>
+          <a:prstGeom prst="roundRect">
+            <a:avLst/>
+          </a:prstGeom>
+          <a:solidFill>
+            <a:srgbClr val="4A5D23"/>
+          </a:solidFill>
+          <a:ln>
+            <a:solidFill>
+              <a:srgbClr val="FFC107"/>
+            </a:solidFill>
+          </a:ln>
+        </p:spPr>
+        <p:style>
+          <a:lnRef idx="1">
+            <a:schemeClr val="accent1"/>
+          </a:lnRef>
+          <a:fillRef idx="3">
+            <a:schemeClr val="accent1"/>
+          </a:fillRef>
+          <a:effectRef idx="2">
+            <a:schemeClr val="accent1"/>
+          </a:effectRef>
+          <a:fontRef idx="minor">
+            <a:schemeClr val="lt1"/>
+          </a:fontRef>
+        </p:style>
+        <p:txBody>
+          <a:bodyPr rtlCol="0" anchor="ctr"/>
+          <a:lstStyle/>
+          <a:p>
+            <a:pPr algn="ctr"/>
+            <a:endParaRPr/>
+          </a:p>
+        </p:txBody>
+      </p:sp>
+      <p:sp>
+        <p:nvSpPr>
+          <p:cNvPr id="12" name="TextBox 11"/>
           <p:cNvSpPr txBox="1"/>
           <p:nvPr/>
         </p:nvSpPr>
         <p:spPr>
           <a:xfrm>
-            <a:off x="3474720" y="3657600"/>
-            <a:ext cx="8229600" cy="2377440"/>
+            <a:off x="6035040" y="2468880"/>
+            <a:ext cx="2560320" cy="822960"/>
           </a:xfrm>
           <a:prstGeom prst="rect">
             <a:avLst/>
@@ -13212,77 +12605,29 @@
           </a:bodyPr>
           <a:lstStyle/>
           <a:p>
-            <a:pPr algn="l"/>
-            <a:r>
-              <a:rPr sz="1400" b="0">
-                <a:solidFill>
-                  <a:srgbClr val="222222"/>
-                </a:solidFill>
-                <a:latin typeface="Calibri"/>
-              </a:rPr>
-              <a:t>•  Master Software Engineering 2025-2026</a:t>
-            </a:r>
-          </a:p>
-          <a:p>
-            <a:pPr algn="l"/>
-            <a:r>
-              <a:rPr sz="1400" b="0">
-                <a:solidFill>
-                  <a:srgbClr val="222222"/>
-                </a:solidFill>
-                <a:latin typeface="Calibri"/>
-              </a:rPr>
-              <a:t>•  ~1 050 commits over 10 maanden · 273 story points · 22 epics</a:t>
-            </a:r>
-          </a:p>
-          <a:p>
-            <a:pPr algn="l"/>
-            <a:r>
-              <a:rPr sz="1400" b="0">
-                <a:solidFill>
-                  <a:srgbClr val="222222"/>
-                </a:solidFill>
-                <a:latin typeface="Calibri"/>
-              </a:rPr>
-              <a:t>•  Diepe ervaring met Python, async I/O, SQLAlchemy, Shiny</a:t>
-            </a:r>
-          </a:p>
-          <a:p>
-            <a:pPr algn="l"/>
-            <a:r>
-              <a:rPr sz="1400" b="0">
-                <a:solidFill>
-                  <a:srgbClr val="222222"/>
-                </a:solidFill>
-                <a:latin typeface="Calibri"/>
-              </a:rPr>
-              <a:t>•  Direct contact met Land-component PTI's voor MFFT 2026 inhoud</a:t>
-            </a:r>
-          </a:p>
-          <a:p>
-            <a:pPr algn="l"/>
-            <a:r>
-              <a:rPr sz="1400" b="0">
-                <a:solidFill>
-                  <a:srgbClr val="222222"/>
-                </a:solidFill>
-                <a:latin typeface="Calibri"/>
-              </a:rPr>
-              <a:t>•  AVG-/security-bewustzijn: OWASP, NIST CSF 2.0, PostgreSQL TLS</a:t>
-            </a:r>
-          </a:p>
-        </p:txBody>
-      </p:sp>
-      <p:sp>
-        <p:nvSpPr>
-          <p:cNvPr id="12" name="TextBox 11"/>
+            <a:pPr algn="ctr"/>
+            <a:r>
+              <a:rPr sz="4000" b="1">
+                <a:solidFill>
+                  <a:srgbClr val="FFC107"/>
+                </a:solidFill>
+                <a:latin typeface="Calibri"/>
+              </a:rPr>
+              <a:t>EN/NL/FR</a:t>
+            </a:r>
+          </a:p>
+        </p:txBody>
+      </p:sp>
+      <p:sp>
+        <p:nvSpPr>
+          <p:cNvPr id="13" name="TextBox 12"/>
           <p:cNvSpPr txBox="1"/>
           <p:nvPr/>
         </p:nvSpPr>
         <p:spPr>
           <a:xfrm>
-            <a:off x="457200" y="6446520"/>
-            <a:ext cx="5486400" cy="365760"/>
+            <a:off x="6035040" y="3383280"/>
+            <a:ext cx="2560320" cy="457200"/>
           </a:xfrm>
           <a:prstGeom prst="rect">
             <a:avLst/>
@@ -13295,29 +12640,75 @@
           </a:bodyPr>
           <a:lstStyle/>
           <a:p>
-            <a:pPr algn="l"/>
-            <a:r>
-              <a:rPr sz="1000" b="0">
-                <a:solidFill>
-                  <a:srgbClr val="555555"/>
-                </a:solidFill>
-                <a:latin typeface="Calibri"/>
-              </a:rPr>
-              <a:t>WarriorFit  ·  Benoit Goethals  ·  2025-2026</a:t>
-            </a:r>
-          </a:p>
-        </p:txBody>
-      </p:sp>
-      <p:sp>
-        <p:nvSpPr>
-          <p:cNvPr id="13" name="TextBox 12"/>
+            <a:pPr algn="ctr"/>
+            <a:r>
+              <a:rPr sz="1200" b="0">
+                <a:solidFill>
+                  <a:srgbClr val="F5F1E6"/>
+                </a:solidFill>
+                <a:latin typeface="Calibri"/>
+              </a:rPr>
+              <a:t>i18n compleet</a:t>
+            </a:r>
+          </a:p>
+        </p:txBody>
+      </p:sp>
+      <p:sp>
+        <p:nvSpPr>
+          <p:cNvPr id="14" name="Rounded Rectangle 13"/>
+          <p:cNvSpPr/>
+          <p:nvPr/>
+        </p:nvSpPr>
+        <p:spPr>
+          <a:xfrm>
+            <a:off x="8778240" y="2194560"/>
+            <a:ext cx="2560320" cy="1828800"/>
+          </a:xfrm>
+          <a:prstGeom prst="roundRect">
+            <a:avLst/>
+          </a:prstGeom>
+          <a:solidFill>
+            <a:srgbClr val="4A5D23"/>
+          </a:solidFill>
+          <a:ln>
+            <a:solidFill>
+              <a:srgbClr val="FFC107"/>
+            </a:solidFill>
+          </a:ln>
+        </p:spPr>
+        <p:style>
+          <a:lnRef idx="1">
+            <a:schemeClr val="accent1"/>
+          </a:lnRef>
+          <a:fillRef idx="3">
+            <a:schemeClr val="accent1"/>
+          </a:fillRef>
+          <a:effectRef idx="2">
+            <a:schemeClr val="accent1"/>
+          </a:effectRef>
+          <a:fontRef idx="minor">
+            <a:schemeClr val="lt1"/>
+          </a:fontRef>
+        </p:style>
+        <p:txBody>
+          <a:bodyPr rtlCol="0" anchor="ctr"/>
+          <a:lstStyle/>
+          <a:p>
+            <a:pPr algn="ctr"/>
+            <a:endParaRPr/>
+          </a:p>
+        </p:txBody>
+      </p:sp>
+      <p:sp>
+        <p:nvSpPr>
+          <p:cNvPr id="15" name="TextBox 14"/>
           <p:cNvSpPr txBox="1"/>
           <p:nvPr/>
         </p:nvSpPr>
         <p:spPr>
           <a:xfrm>
-            <a:off x="10789920" y="6446520"/>
-            <a:ext cx="1097280" cy="365760"/>
+            <a:off x="8778240" y="2468880"/>
+            <a:ext cx="2560320" cy="822960"/>
           </a:xfrm>
           <a:prstGeom prst="rect">
             <a:avLst/>
@@ -13330,15 +12721,179 @@
           </a:bodyPr>
           <a:lstStyle/>
           <a:p>
-            <a:pPr algn="r"/>
-            <a:r>
-              <a:rPr sz="1000" b="0">
-                <a:solidFill>
-                  <a:srgbClr val="555555"/>
-                </a:solidFill>
-                <a:latin typeface="Calibri"/>
-              </a:rPr>
-              <a:t>9 / 10</a:t>
+            <a:pPr algn="ctr"/>
+            <a:r>
+              <a:rPr sz="4000" b="1">
+                <a:solidFill>
+                  <a:srgbClr val="FFC107"/>
+                </a:solidFill>
+                <a:latin typeface="Calibri"/>
+              </a:rPr>
+              <a:t>AVG ✓</a:t>
+            </a:r>
+          </a:p>
+        </p:txBody>
+      </p:sp>
+      <p:sp>
+        <p:nvSpPr>
+          <p:cNvPr id="16" name="TextBox 15"/>
+          <p:cNvSpPr txBox="1"/>
+          <p:nvPr/>
+        </p:nvSpPr>
+        <p:spPr>
+          <a:xfrm>
+            <a:off x="8778240" y="3383280"/>
+            <a:ext cx="2560320" cy="457200"/>
+          </a:xfrm>
+          <a:prstGeom prst="rect">
+            <a:avLst/>
+          </a:prstGeom>
+          <a:noFill/>
+        </p:spPr>
+        <p:txBody>
+          <a:bodyPr wrap="square" lIns="45720" rIns="45720">
+            <a:spAutoFit/>
+          </a:bodyPr>
+          <a:lstStyle/>
+          <a:p>
+            <a:pPr algn="ctr"/>
+            <a:r>
+              <a:rPr sz="1200" b="0">
+                <a:solidFill>
+                  <a:srgbClr val="F5F1E6"/>
+                </a:solidFill>
+                <a:latin typeface="Calibri"/>
+              </a:rPr>
+              <a:t>GDPR compliant</a:t>
+            </a:r>
+          </a:p>
+        </p:txBody>
+      </p:sp>
+      <p:sp>
+        <p:nvSpPr>
+          <p:cNvPr id="17" name="TextBox 16"/>
+          <p:cNvSpPr txBox="1"/>
+          <p:nvPr/>
+        </p:nvSpPr>
+        <p:spPr>
+          <a:xfrm>
+            <a:off x="548640" y="4389120"/>
+            <a:ext cx="10972800" cy="457200"/>
+          </a:xfrm>
+          <a:prstGeom prst="rect">
+            <a:avLst/>
+          </a:prstGeom>
+          <a:noFill/>
+        </p:spPr>
+        <p:txBody>
+          <a:bodyPr wrap="square" lIns="45720" rIns="45720">
+            <a:spAutoFit/>
+          </a:bodyPr>
+          <a:lstStyle/>
+          <a:p>
+            <a:pPr algn="l"/>
+            <a:r>
+              <a:rPr sz="1400" b="1">
+                <a:solidFill>
+                  <a:srgbClr val="FFC107"/>
+                </a:solidFill>
+                <a:latin typeface="Calibri"/>
+              </a:rPr>
+              <a:t>DE VRAAG</a:t>
+            </a:r>
+          </a:p>
+        </p:txBody>
+      </p:sp>
+      <p:sp>
+        <p:nvSpPr>
+          <p:cNvPr id="18" name="TextBox 17"/>
+          <p:cNvSpPr txBox="1"/>
+          <p:nvPr/>
+        </p:nvSpPr>
+        <p:spPr>
+          <a:xfrm>
+            <a:off x="548640" y="4754880"/>
+            <a:ext cx="10972800" cy="1645920"/>
+          </a:xfrm>
+          <a:prstGeom prst="rect">
+            <a:avLst/>
+          </a:prstGeom>
+          <a:noFill/>
+        </p:spPr>
+        <p:txBody>
+          <a:bodyPr wrap="square" lIns="45720" rIns="45720">
+            <a:spAutoFit/>
+          </a:bodyPr>
+          <a:lstStyle/>
+          <a:p>
+            <a:pPr algn="l"/>
+            <a:r>
+              <a:rPr sz="2000" b="0">
+                <a:solidFill>
+                  <a:srgbClr val="FFFFFF"/>
+                </a:solidFill>
+                <a:latin typeface="Calibri"/>
+              </a:rPr>
+              <a:t>→  Pilot-deployment in één SOR-eenheid (Q3 2026)</a:t>
+            </a:r>
+          </a:p>
+          <a:p>
+            <a:pPr algn="l"/>
+            <a:r>
+              <a:rPr sz="2000" b="0">
+                <a:solidFill>
+                  <a:srgbClr val="FFFFFF"/>
+                </a:solidFill>
+                <a:latin typeface="Calibri"/>
+              </a:rPr>
+              <a:t>→  Toegang tot BEMIL-API voor productie-koppeling</a:t>
+            </a:r>
+          </a:p>
+          <a:p>
+            <a:pPr algn="l"/>
+            <a:r>
+              <a:rPr sz="2000" b="0">
+                <a:solidFill>
+                  <a:srgbClr val="FFFFFF"/>
+                </a:solidFill>
+                <a:latin typeface="Calibri"/>
+              </a:rPr>
+              <a:t>→  Feedback van PTI's tijdens MFFT-rollout 2026</a:t>
+            </a:r>
+          </a:p>
+        </p:txBody>
+      </p:sp>
+      <p:sp>
+        <p:nvSpPr>
+          <p:cNvPr id="19" name="TextBox 18"/>
+          <p:cNvSpPr txBox="1"/>
+          <p:nvPr/>
+        </p:nvSpPr>
+        <p:spPr>
+          <a:xfrm>
+            <a:off x="548640" y="6446520"/>
+            <a:ext cx="10972800" cy="365760"/>
+          </a:xfrm>
+          <a:prstGeom prst="rect">
+            <a:avLst/>
+          </a:prstGeom>
+          <a:noFill/>
+        </p:spPr>
+        <p:txBody>
+          <a:bodyPr wrap="square" lIns="45720" rIns="45720">
+            <a:spAutoFit/>
+          </a:bodyPr>
+          <a:lstStyle/>
+          <a:p>
+            <a:pPr algn="l"/>
+            <a:r>
+              <a:rPr sz="1100" b="0">
+                <a:solidFill>
+                  <a:srgbClr val="C3B091"/>
+                </a:solidFill>
+                <a:latin typeface="Calibri"/>
+              </a:rPr>
+              <a:t>benoit.goethals@gmail.com  ·  github.com/BenoitGoethals/WarriorFit</a:t>
             </a:r>
           </a:p>
         </p:txBody>

</xml_diff>